<commit_message>
docs(demo): refresh CI, GHCR and Argo CD evidence from the recreated repository
</commit_message>
<xml_diff>
--- a/demo/TaskBoard-DevSecOps-Capstone.pptx
+++ b/demo/TaskBoard-DevSecOps-Capstone.pptx
@@ -123,31 +123,31 @@
   <p:extLst>
     <p:ext uri="{521415D9-36F7-43E2-AB2F-B90AF26B5E84}">
       <p14:sectionLst xmlns:p14="http://schemas.microsoft.com/office/powerpoint/2010/main">
-        <p14:section name="Introduction" id="{96f4f4f8-3579-4469-6ac4-6e4979d4c20d}">
+        <p14:section name="Introduction" id="{8043cffe-dbd8-8bb0-e7d6-f529f65beec9}">
           <p14:sldIdLst>
             <p14:sldId id="256"/>
             <p14:sldId id="257"/>
           </p14:sldIdLst>
         </p14:section>
-        <p14:section name="Application" id="{7d9ead86-f8c9-90a9-bc47-9b0e95316413}">
+        <p14:section name="Application" id="{31c6d1f9-f7d1-d43e-5826-28fe3738fec0}">
           <p14:sldIdLst>
             <p14:sldId id="258"/>
             <p14:sldId id="259"/>
           </p14:sldIdLst>
         </p14:section>
-        <p14:section name="Architecture" id="{1fa83653-1428-7f1b-1ae5-3850d904af5e}">
+        <p14:section name="Architecture" id="{f4b56cba-cf8e-7861-41c9-0f9b5b7a406d}">
           <p14:sldIdLst>
             <p14:sldId id="260"/>
           </p14:sldIdLst>
         </p14:section>
-        <p14:section name="Pipeline" id="{199c6b95-5b84-f90d-bd71-e5ce8ec91264}">
+        <p14:section name="Pipeline" id="{a448d9ec-ff34-935f-dc28-3e34cd0c05fb}">
           <p14:sldIdLst>
             <p14:sldId id="261"/>
             <p14:sldId id="262"/>
             <p14:sldId id="263"/>
           </p14:sldIdLst>
         </p14:section>
-        <p14:section name="Infrastructure" id="{8705b8ec-2e1f-5ebb-52ed-c8cab0be671f}">
+        <p14:section name="Infrastructure" id="{9194fbf2-f2fe-9022-58ed-d1e1f94456ff}">
           <p14:sldIdLst>
             <p14:sldId id="264"/>
             <p14:sldId id="265"/>
@@ -155,7 +155,7 @@
             <p14:sldId id="267"/>
           </p14:sldIdLst>
         </p14:section>
-        <p14:section name="Operations" id="{91075b5e-b320-692e-8027-6eb8dba709dc}">
+        <p14:section name="Operations" id="{bf80f5dd-01bc-e87a-6e7a-9f55214b52d9}">
           <p14:sldIdLst>
             <p14:sldId id="268"/>
             <p14:sldId id="269"/>

</xml_diff>